<commit_message>
Prezentare: slide-uri Directii viitoare + Bibliografie selectiva
- slide "Directii viitoare de cercetare" (calibrare SIDARTHE pe date bogate,
  calibrare bivariata, LSTM hibrid, GPU, teste e2e + observabilitate)
- slide "Bibliografie selectiva" cu 9 referinte fundamentale
- ambele inainte de slide-ul de multumire, cu note de prezentator
- 21 slide-uri
</commit_message>
<xml_diff>
--- a/docs/Disertatie_prezentare.pptx
+++ b/docs/Disertatie_prezentare.pptx
@@ -24,6 +24,8 @@
     <p:sldId id="272" r:id="rId23"/>
     <p:sldId id="273" r:id="rId24"/>
     <p:sldId id="274" r:id="rId25"/>
+    <p:sldId id="275" r:id="rId26"/>
+    <p:sldId id="276" r:id="rId27"/>
   </p:sldIdLst>
   <p:sldSz cx="12191695" cy="6858000" type="screen4x3"/>
   <p:notesSz cx="6858000" cy="9144000"/>
@@ -1220,7 +1222,7 @@
           <a:lstStyle/>
           <a:p>
             <a:r>
-              <a:t>Cu aceasta închei prezentarea. Vă mulțumesc pentru atenție și sunt pregătit să răspund la întrebările dumneavoastră. Vă stau la dispoziție pentru orice clarificare legată de modelele matematice, de implementarea în cele trei limbaje sau de rezultatele experimentale.</a:t>
+              <a:t>Lucrarea deschide mai multe direcții de cercetare. Cea mai importantă este calibrarea modelului SIDARTHE pe date mai bogate — testare, spitalizare, terapie intensivă — folosind operatori de observație multipli, ca să pot constrânge separat grupuri de parametri. Un prim pas concret, deja pregătit de îmbogățirea schemei de date, este calibrarea bivariată, care fitează simultan cazurile și decesele și rupe valea de identifiabilitate slabă pe care am arătat-o la SIR. Pe partea predictivă, direcția naturală este varianta hibridă, în care LSTM-ul învață reziduurile modelului compartimental, testată pe toate cele 38 de țări din setul OWID. Tehnic, urmează promovarea calibrării într-un job asincron în aplicație, extinderea benchmark-ului pe alt hardware, inclusiv GPU pentru LSTM, și, pe partea operațională, o suită de teste end-to-end, autoscalare orizontală și un stack de observabilitate cu Prometheus și Grafana.</a:t>
             </a:r>
           </a:p>
         </p:txBody>
@@ -1291,6 +1293,146 @@
           <a:p>
             <a:r>
               <a:t>Pornesc de la o observație simplă, dar importantă: bolile infecțioase nu sunt doar un fenomen clinic, ci unul populațional. Felul în care se răspândește un agent patogen depinde de contacte, de mobilitate, de modul de raportare și de capacitatea de răspuns a sistemului sanitar. Pandemiile recente — gripa din 1918, SARS-ul din 2003, COVID-19 — au arătat asta foarte clar. Modelele compartimentale, începând cu modelul SIR formulat de Kermack și McKendrick în 1927, ne oferă un limbaj matematic riguros pentru a descrie această dinamică prin ecuații diferențiale. Însă în practica reală problema nu se oprește la scrierea ecuațiilor. Datele epidemiologice vin din surse eterogene, au goluri și corecții administrative. Iar implementarea numerică poate fi făcută în limbaje diferite — R, Julia, Python — fiecare cu costuri proprii de timp, de memorie și de reproductibilitate. De aceea, ideea centrală a lucrării este să leg explicit partea de modelare matematică de partea de implementare software, într-un cadru unitar și reproductibil.</a:t>
+            </a:r>
+          </a:p>
+        </p:txBody>
+      </p:sp>
+      <p:sp>
+        <p:nvSpPr>
+          <p:cNvPr id="4" name="Slide Number Placeholder 3"/>
+          <p:cNvSpPr>
+            <a:spLocks noGrp="1"/>
+          </p:cNvSpPr>
+          <p:nvPr>
+            <p:ph type="sldNum" idx="5" sz="quarter"/>
+          </p:nvPr>
+        </p:nvSpPr>
+        <p:spPr/>
+      </p:sp>
+    </p:spTree>
+  </p:cSld>
+  <p:clrMapOvr>
+    <a:masterClrMapping/>
+  </p:clrMapOvr>
+</p:notes>
+</file>
+
+<file path=ppt/notesSlides/notesSlide20.xml><?xml version="1.0" encoding="utf-8"?>
+<p:notes xmlns:a="http://schemas.openxmlformats.org/drawingml/2006/main" xmlns:p="http://schemas.openxmlformats.org/presentationml/2006/main" xmlns:r="http://schemas.openxmlformats.org/officeDocument/2006/relationships">
+  <p:cSld>
+    <p:spTree>
+      <p:nvGrpSpPr>
+        <p:cNvPr id="1" name=""/>
+        <p:cNvGrpSpPr/>
+        <p:nvPr/>
+      </p:nvGrpSpPr>
+      <p:grpSpPr>
+        <a:xfrm>
+          <a:off x="0" y="0"/>
+          <a:ext cx="0" cy="0"/>
+          <a:chOff x="0" y="0"/>
+          <a:chExt cx="0" cy="0"/>
+        </a:xfrm>
+      </p:grpSpPr>
+      <p:sp>
+        <p:nvSpPr>
+          <p:cNvPr id="2" name="Slide Image Placeholder 1"/>
+          <p:cNvSpPr>
+            <a:spLocks noGrp="1"/>
+          </p:cNvSpPr>
+          <p:nvPr>
+            <p:ph type="sldImg" idx="2"/>
+          </p:nvPr>
+        </p:nvSpPr>
+        <p:spPr/>
+      </p:sp>
+      <p:sp>
+        <p:nvSpPr>
+          <p:cNvPr id="3" name="Notes Placeholder 2"/>
+          <p:cNvSpPr>
+            <a:spLocks noGrp="1"/>
+          </p:cNvSpPr>
+          <p:nvPr>
+            <p:ph type="body" idx="3" sz="quarter"/>
+          </p:nvPr>
+        </p:nvSpPr>
+        <p:spPr/>
+        <p:txBody>
+          <a:bodyPr/>
+          <a:lstStyle/>
+          <a:p>
+            <a:r>
+              <a:t>În final, principalele referințe ale lucrării. Pe partea de modelare epidemiologică: articolul clasic Kermack și McKendrick din 1927, care introduce modelul SIR; articolul Giordano și colaboratorii din 2020 din Nature Medicine, care propune modelul SIDARTHE; sinteza lui Hethcote despre matematica bolilor infecțioase; și Diekmann, pentru definiția riguroasă a numărului de reproducere prin matricea generației următoare. Pe partea numerică: perechea Dormand-Prince, pentru metoda RK45, și documentația celor trei biblioteci de solvere folosite — deSolve, DifferentialEquations.jl și SciPy. Iar pentru componenta predictivă, articolul original Hochreiter și Schmidhuber, care introduce rețelele LSTM. Lista completă, de peste treizeci de referințe, se află în bibliografia tezei.</a:t>
+            </a:r>
+          </a:p>
+        </p:txBody>
+      </p:sp>
+      <p:sp>
+        <p:nvSpPr>
+          <p:cNvPr id="4" name="Slide Number Placeholder 3"/>
+          <p:cNvSpPr>
+            <a:spLocks noGrp="1"/>
+          </p:cNvSpPr>
+          <p:nvPr>
+            <p:ph type="sldNum" idx="5" sz="quarter"/>
+          </p:nvPr>
+        </p:nvSpPr>
+        <p:spPr/>
+      </p:sp>
+    </p:spTree>
+  </p:cSld>
+  <p:clrMapOvr>
+    <a:masterClrMapping/>
+  </p:clrMapOvr>
+</p:notes>
+</file>
+
+<file path=ppt/notesSlides/notesSlide21.xml><?xml version="1.0" encoding="utf-8"?>
+<p:notes xmlns:a="http://schemas.openxmlformats.org/drawingml/2006/main" xmlns:p="http://schemas.openxmlformats.org/presentationml/2006/main" xmlns:r="http://schemas.openxmlformats.org/officeDocument/2006/relationships">
+  <p:cSld>
+    <p:spTree>
+      <p:nvGrpSpPr>
+        <p:cNvPr id="1" name=""/>
+        <p:cNvGrpSpPr/>
+        <p:nvPr/>
+      </p:nvGrpSpPr>
+      <p:grpSpPr>
+        <a:xfrm>
+          <a:off x="0" y="0"/>
+          <a:ext cx="0" cy="0"/>
+          <a:chOff x="0" y="0"/>
+          <a:chExt cx="0" cy="0"/>
+        </a:xfrm>
+      </p:grpSpPr>
+      <p:sp>
+        <p:nvSpPr>
+          <p:cNvPr id="2" name="Slide Image Placeholder 1"/>
+          <p:cNvSpPr>
+            <a:spLocks noGrp="1"/>
+          </p:cNvSpPr>
+          <p:nvPr>
+            <p:ph type="sldImg" idx="2"/>
+          </p:nvPr>
+        </p:nvSpPr>
+        <p:spPr/>
+      </p:sp>
+      <p:sp>
+        <p:nvSpPr>
+          <p:cNvPr id="3" name="Notes Placeholder 2"/>
+          <p:cNvSpPr>
+            <a:spLocks noGrp="1"/>
+          </p:cNvSpPr>
+          <p:nvPr>
+            <p:ph type="body" idx="3" sz="quarter"/>
+          </p:nvPr>
+        </p:nvSpPr>
+        <p:spPr/>
+        <p:txBody>
+          <a:bodyPr/>
+          <a:lstStyle/>
+          <a:p>
+            <a:r>
+              <a:t>Cu aceasta închei prezentarea. Vă mulțumesc pentru atenție și sunt pregătit să răspund la întrebările dumneavoastră. Vă stau la dispoziție pentru orice clarificare legată de modelele matematice, de implementarea în cele trei limbaje sau de rezultatele experimentale.</a:t>
             </a:r>
           </a:p>
         </p:txBody>
@@ -7946,51 +8088,7 @@
         <p:spPr>
           <a:xfrm>
             <a:off x="0" y="0"/>
-            <a:ext cx="12191695" cy="6858000"/>
-          </a:xfrm>
-          <a:prstGeom prst="rect">
-            <a:avLst/>
-          </a:prstGeom>
-          <a:solidFill>
-            <a:srgbClr val="FFFFFF"/>
-          </a:solidFill>
-          <a:ln>
-            <a:noFill/>
-          </a:ln>
-          <a:effectLst/>
-        </p:spPr>
-        <p:style>
-          <a:lnRef idx="1">
-            <a:schemeClr val="accent1"/>
-          </a:lnRef>
-          <a:fillRef idx="3">
-            <a:schemeClr val="accent1"/>
-          </a:fillRef>
-          <a:effectRef idx="2">
-            <a:schemeClr val="accent1"/>
-          </a:effectRef>
-          <a:fontRef idx="minor">
-            <a:schemeClr val="lt1"/>
-          </a:fontRef>
-        </p:style>
-        <p:txBody>
-          <a:bodyPr rtlCol="0" anchor="ctr"/>
-          <a:lstStyle/>
-          <a:p>
-            <a:pPr algn="ctr"/>
-          </a:p>
-        </p:txBody>
-      </p:sp>
-      <p:sp>
-        <p:nvSpPr>
-          <p:cNvPr id="3" name="Rectangle 2"/>
-          <p:cNvSpPr/>
-          <p:nvPr/>
-        </p:nvSpPr>
-        <p:spPr>
-          <a:xfrm>
-            <a:off x="0" y="2468880"/>
-            <a:ext cx="12191695" cy="1920240"/>
+            <a:ext cx="12191695" cy="960120"/>
           </a:xfrm>
           <a:prstGeom prst="rect">
             <a:avLst/>
@@ -8027,14 +8125,58 @@
       </p:sp>
       <p:sp>
         <p:nvSpPr>
+          <p:cNvPr id="3" name="Rectangle 2"/>
+          <p:cNvSpPr/>
+          <p:nvPr/>
+        </p:nvSpPr>
+        <p:spPr>
+          <a:xfrm>
+            <a:off x="0" y="960120"/>
+            <a:ext cx="12191695" cy="45720"/>
+          </a:xfrm>
+          <a:prstGeom prst="rect">
+            <a:avLst/>
+          </a:prstGeom>
+          <a:solidFill>
+            <a:srgbClr val="1E88A8"/>
+          </a:solidFill>
+          <a:ln>
+            <a:noFill/>
+          </a:ln>
+          <a:effectLst/>
+        </p:spPr>
+        <p:style>
+          <a:lnRef idx="1">
+            <a:schemeClr val="accent1"/>
+          </a:lnRef>
+          <a:fillRef idx="3">
+            <a:schemeClr val="accent1"/>
+          </a:fillRef>
+          <a:effectRef idx="2">
+            <a:schemeClr val="accent1"/>
+          </a:effectRef>
+          <a:fontRef idx="minor">
+            <a:schemeClr val="lt1"/>
+          </a:fontRef>
+        </p:style>
+        <p:txBody>
+          <a:bodyPr rtlCol="0" anchor="ctr"/>
+          <a:lstStyle/>
+          <a:p>
+            <a:pPr algn="ctr"/>
+          </a:p>
+        </p:txBody>
+      </p:sp>
+      <p:sp>
+        <p:nvSpPr>
           <p:cNvPr id="4" name="TextBox 3"/>
           <p:cNvSpPr txBox="1"/>
           <p:nvPr/>
         </p:nvSpPr>
         <p:spPr>
           <a:xfrm>
-            <a:off x="640080" y="2468880"/>
-            <a:ext cx="10972800" cy="1920240"/>
+            <a:off x="502920" y="73152"/>
+            <a:ext cx="11155680" cy="822960"/>
           </a:xfrm>
           <a:prstGeom prst="rect">
             <a:avLst/>
@@ -8047,31 +8189,251 @@
           </a:bodyPr>
           <a:lstStyle/>
           <a:p>
-            <a:pPr algn="ctr"/>
-            <a:r>
-              <a:rPr sz="4000" b="1" i="0">
+            <a:r>
+              <a:rPr sz="1300" b="1" i="0">
+                <a:solidFill>
+                  <a:srgbClr val="BFDDE6"/>
+                </a:solidFill>
+                <a:latin typeface="Calibri"/>
+              </a:rPr>
+              <a:t>Perspective</a:t>
+            </a:r>
+          </a:p>
+          <a:p>
+            <a:r>
+              <a:rPr sz="3000" b="1" i="0">
                 <a:solidFill>
                   <a:srgbClr val="FFFFFF"/>
                 </a:solidFill>
                 <a:latin typeface="Calibri"/>
               </a:rPr>
-              <a:t>Vă mulțumesc!   Întrebări?</a:t>
-            </a:r>
-          </a:p>
-          <a:p>
-            <a:pPr algn="ctr">
+              <a:t>Direcții viitoare de cercetare</a:t>
+            </a:r>
+          </a:p>
+        </p:txBody>
+      </p:sp>
+      <p:sp>
+        <p:nvSpPr>
+          <p:cNvPr id="5" name="TextBox 4"/>
+          <p:cNvSpPr txBox="1"/>
+          <p:nvPr/>
+        </p:nvSpPr>
+        <p:spPr>
+          <a:xfrm>
+            <a:off x="731520" y="1371600"/>
+            <a:ext cx="10789920" cy="4754880"/>
+          </a:xfrm>
+          <a:prstGeom prst="rect">
+            <a:avLst/>
+          </a:prstGeom>
+          <a:noFill/>
+        </p:spPr>
+        <p:txBody>
+          <a:bodyPr wrap="square" anchor="ctr" lIns="36576" rIns="36576" tIns="36576" bIns="36576">
+            <a:spAutoFit/>
+          </a:bodyPr>
+          <a:lstStyle/>
+          <a:p>
+            <a:pPr>
               <a:spcBef>
-                <a:spcPts val="1000"/>
+                <a:spcPts val="0"/>
               </a:spcBef>
+              <a:spcAft>
+                <a:spcPts val="1400"/>
+              </a:spcAft>
             </a:pPr>
             <a:r>
-              <a:rPr sz="1600" b="0" i="0">
-                <a:solidFill>
-                  <a:srgbClr val="CFE6EE"/>
-                </a:solidFill>
-                <a:latin typeface="Calibri"/>
-              </a:rPr>
-              <a:t>Geană Tudor-Bogdan  ·  Coordonator: Prof. Radu Rădescu</a:t>
+              <a:rPr sz="2400" b="1" i="0">
+                <a:solidFill>
+                  <a:srgbClr val="1E88A8"/>
+                </a:solidFill>
+                <a:latin typeface="Calibri"/>
+              </a:rPr>
+              <a:t>▸  </a:t>
+            </a:r>
+            <a:r>
+              <a:rPr sz="2400" b="0" i="0">
+                <a:solidFill>
+                  <a:srgbClr val="20282C"/>
+                </a:solidFill>
+                <a:latin typeface="Calibri"/>
+              </a:rPr>
+              <a:t>Calibrare SIDARTHE pe date bogate (testare, spitalizare, ATI)</a:t>
+            </a:r>
+          </a:p>
+          <a:p>
+            <a:pPr>
+              <a:spcBef>
+                <a:spcPts val="0"/>
+              </a:spcBef>
+              <a:spcAft>
+                <a:spcPts val="1400"/>
+              </a:spcAft>
+            </a:pPr>
+            <a:r>
+              <a:rPr sz="2400" b="1" i="0">
+                <a:solidFill>
+                  <a:srgbClr val="1E88A8"/>
+                </a:solidFill>
+                <a:latin typeface="Calibri"/>
+              </a:rPr>
+              <a:t>▸  </a:t>
+            </a:r>
+            <a:r>
+              <a:rPr sz="2400" b="0" i="0">
+                <a:solidFill>
+                  <a:srgbClr val="20282C"/>
+                </a:solidFill>
+                <a:latin typeface="Calibri"/>
+              </a:rPr>
+              <a:t>Calibrare bivariată (I + D) — rupe valea de identifiabilitate</a:t>
+            </a:r>
+          </a:p>
+          <a:p>
+            <a:pPr>
+              <a:spcBef>
+                <a:spcPts val="0"/>
+              </a:spcBef>
+              <a:spcAft>
+                <a:spcPts val="1400"/>
+              </a:spcAft>
+            </a:pPr>
+            <a:r>
+              <a:rPr sz="2400" b="1" i="0">
+                <a:solidFill>
+                  <a:srgbClr val="1E88A8"/>
+                </a:solidFill>
+                <a:latin typeface="Calibri"/>
+              </a:rPr>
+              <a:t>▸  </a:t>
+            </a:r>
+            <a:r>
+              <a:rPr sz="2400" b="0" i="0">
+                <a:solidFill>
+                  <a:srgbClr val="20282C"/>
+                </a:solidFill>
+                <a:latin typeface="Calibri"/>
+              </a:rPr>
+              <a:t>LSTM hibrid peste reziduuri, pe toate cele 38 de țări OWID</a:t>
+            </a:r>
+          </a:p>
+          <a:p>
+            <a:pPr>
+              <a:spcBef>
+                <a:spcPts val="0"/>
+              </a:spcBef>
+              <a:spcAft>
+                <a:spcPts val="1400"/>
+              </a:spcAft>
+            </a:pPr>
+            <a:r>
+              <a:rPr sz="2400" b="1" i="0">
+                <a:solidFill>
+                  <a:srgbClr val="1E88A8"/>
+                </a:solidFill>
+                <a:latin typeface="Calibri"/>
+              </a:rPr>
+              <a:t>▸  </a:t>
+            </a:r>
+            <a:r>
+              <a:rPr sz="2400" b="0" i="0">
+                <a:solidFill>
+                  <a:srgbClr val="20282C"/>
+                </a:solidFill>
+                <a:latin typeface="Calibri"/>
+              </a:rPr>
+              <a:t>Calibrarea ca job asincron în aplicație</a:t>
+            </a:r>
+          </a:p>
+          <a:p>
+            <a:pPr>
+              <a:spcBef>
+                <a:spcPts val="0"/>
+              </a:spcBef>
+              <a:spcAft>
+                <a:spcPts val="1400"/>
+              </a:spcAft>
+            </a:pPr>
+            <a:r>
+              <a:rPr sz="2400" b="1" i="0">
+                <a:solidFill>
+                  <a:srgbClr val="1E88A8"/>
+                </a:solidFill>
+                <a:latin typeface="Calibri"/>
+              </a:rPr>
+              <a:t>▸  </a:t>
+            </a:r>
+            <a:r>
+              <a:rPr sz="2400" b="0" i="0">
+                <a:solidFill>
+                  <a:srgbClr val="20282C"/>
+                </a:solidFill>
+                <a:latin typeface="Calibri"/>
+              </a:rPr>
+              <a:t>Benchmark pe alt hardware (GPU pentru LSTM)</a:t>
+            </a:r>
+          </a:p>
+          <a:p>
+            <a:pPr>
+              <a:spcBef>
+                <a:spcPts val="0"/>
+              </a:spcBef>
+              <a:spcAft>
+                <a:spcPts val="1400"/>
+              </a:spcAft>
+            </a:pPr>
+            <a:r>
+              <a:rPr sz="2400" b="1" i="0">
+                <a:solidFill>
+                  <a:srgbClr val="1E88A8"/>
+                </a:solidFill>
+                <a:latin typeface="Calibri"/>
+              </a:rPr>
+              <a:t>▸  </a:t>
+            </a:r>
+            <a:r>
+              <a:rPr sz="2400" b="0" i="0">
+                <a:solidFill>
+                  <a:srgbClr val="20282C"/>
+                </a:solidFill>
+                <a:latin typeface="Calibri"/>
+              </a:rPr>
+              <a:t>Teste e2e · autoscalare (HPA) · observabilitate (Prometheus + Grafana)</a:t>
+            </a:r>
+          </a:p>
+        </p:txBody>
+      </p:sp>
+      <p:sp>
+        <p:nvSpPr>
+          <p:cNvPr id="6" name="TextBox 5"/>
+          <p:cNvSpPr txBox="1"/>
+          <p:nvPr/>
+        </p:nvSpPr>
+        <p:spPr>
+          <a:xfrm>
+            <a:off x="11247120" y="6437376"/>
+            <a:ext cx="822960" cy="365760"/>
+          </a:xfrm>
+          <a:prstGeom prst="rect">
+            <a:avLst/>
+          </a:prstGeom>
+          <a:noFill/>
+        </p:spPr>
+        <p:txBody>
+          <a:bodyPr wrap="square" anchor="t" lIns="36576" rIns="36576" tIns="36576" bIns="36576">
+            <a:spAutoFit/>
+          </a:bodyPr>
+          <a:lstStyle/>
+          <a:p>
+            <a:pPr algn="r"/>
+            <a:r>
+              <a:rPr sz="1200" b="1" i="0">
+                <a:solidFill>
+                  <a:srgbClr val="6B767C"/>
+                </a:solidFill>
+                <a:latin typeface="Calibri"/>
+              </a:rPr>
+              <a:t>18</a:t>
             </a:r>
           </a:p>
         </p:txBody>
@@ -8393,6 +8755,597 @@
                 <a:latin typeface="Calibri"/>
               </a:rPr>
               <a:t>1</a:t>
+            </a:r>
+          </a:p>
+        </p:txBody>
+      </p:sp>
+    </p:spTree>
+  </p:cSld>
+  <p:clrMapOvr>
+    <a:masterClrMapping/>
+  </p:clrMapOvr>
+</p:sld>
+</file>
+
+<file path=ppt/slides/slide20.xml><?xml version="1.0" encoding="utf-8"?>
+<p:sld xmlns:a="http://schemas.openxmlformats.org/drawingml/2006/main" xmlns:p="http://schemas.openxmlformats.org/presentationml/2006/main" xmlns:r="http://schemas.openxmlformats.org/officeDocument/2006/relationships">
+  <p:cSld>
+    <p:spTree>
+      <p:nvGrpSpPr>
+        <p:cNvPr id="1" name=""/>
+        <p:cNvGrpSpPr/>
+        <p:nvPr/>
+      </p:nvGrpSpPr>
+      <p:grpSpPr/>
+      <p:sp>
+        <p:nvSpPr>
+          <p:cNvPr id="2" name="Rectangle 1"/>
+          <p:cNvSpPr/>
+          <p:nvPr/>
+        </p:nvSpPr>
+        <p:spPr>
+          <a:xfrm>
+            <a:off x="0" y="0"/>
+            <a:ext cx="12191695" cy="960120"/>
+          </a:xfrm>
+          <a:prstGeom prst="rect">
+            <a:avLst/>
+          </a:prstGeom>
+          <a:solidFill>
+            <a:srgbClr val="124A63"/>
+          </a:solidFill>
+          <a:ln>
+            <a:noFill/>
+          </a:ln>
+          <a:effectLst/>
+        </p:spPr>
+        <p:style>
+          <a:lnRef idx="1">
+            <a:schemeClr val="accent1"/>
+          </a:lnRef>
+          <a:fillRef idx="3">
+            <a:schemeClr val="accent1"/>
+          </a:fillRef>
+          <a:effectRef idx="2">
+            <a:schemeClr val="accent1"/>
+          </a:effectRef>
+          <a:fontRef idx="minor">
+            <a:schemeClr val="lt1"/>
+          </a:fontRef>
+        </p:style>
+        <p:txBody>
+          <a:bodyPr rtlCol="0" anchor="ctr"/>
+          <a:lstStyle/>
+          <a:p>
+            <a:pPr algn="ctr"/>
+          </a:p>
+        </p:txBody>
+      </p:sp>
+      <p:sp>
+        <p:nvSpPr>
+          <p:cNvPr id="3" name="Rectangle 2"/>
+          <p:cNvSpPr/>
+          <p:nvPr/>
+        </p:nvSpPr>
+        <p:spPr>
+          <a:xfrm>
+            <a:off x="0" y="960120"/>
+            <a:ext cx="12191695" cy="45720"/>
+          </a:xfrm>
+          <a:prstGeom prst="rect">
+            <a:avLst/>
+          </a:prstGeom>
+          <a:solidFill>
+            <a:srgbClr val="1E88A8"/>
+          </a:solidFill>
+          <a:ln>
+            <a:noFill/>
+          </a:ln>
+          <a:effectLst/>
+        </p:spPr>
+        <p:style>
+          <a:lnRef idx="1">
+            <a:schemeClr val="accent1"/>
+          </a:lnRef>
+          <a:fillRef idx="3">
+            <a:schemeClr val="accent1"/>
+          </a:fillRef>
+          <a:effectRef idx="2">
+            <a:schemeClr val="accent1"/>
+          </a:effectRef>
+          <a:fontRef idx="minor">
+            <a:schemeClr val="lt1"/>
+          </a:fontRef>
+        </p:style>
+        <p:txBody>
+          <a:bodyPr rtlCol="0" anchor="ctr"/>
+          <a:lstStyle/>
+          <a:p>
+            <a:pPr algn="ctr"/>
+          </a:p>
+        </p:txBody>
+      </p:sp>
+      <p:sp>
+        <p:nvSpPr>
+          <p:cNvPr id="4" name="TextBox 3"/>
+          <p:cNvSpPr txBox="1"/>
+          <p:nvPr/>
+        </p:nvSpPr>
+        <p:spPr>
+          <a:xfrm>
+            <a:off x="502920" y="73152"/>
+            <a:ext cx="11155680" cy="822960"/>
+          </a:xfrm>
+          <a:prstGeom prst="rect">
+            <a:avLst/>
+          </a:prstGeom>
+          <a:noFill/>
+        </p:spPr>
+        <p:txBody>
+          <a:bodyPr wrap="square" anchor="ctr" lIns="36576" rIns="36576" tIns="36576" bIns="36576">
+            <a:spAutoFit/>
+          </a:bodyPr>
+          <a:lstStyle/>
+          <a:p>
+            <a:r>
+              <a:rPr sz="1300" b="1" i="0">
+                <a:solidFill>
+                  <a:srgbClr val="BFDDE6"/>
+                </a:solidFill>
+                <a:latin typeface="Calibri"/>
+              </a:rPr>
+              <a:t>Referințe</a:t>
+            </a:r>
+          </a:p>
+          <a:p>
+            <a:r>
+              <a:rPr sz="3000" b="1" i="0">
+                <a:solidFill>
+                  <a:srgbClr val="FFFFFF"/>
+                </a:solidFill>
+                <a:latin typeface="Calibri"/>
+              </a:rPr>
+              <a:t>Bibliografie selectivă</a:t>
+            </a:r>
+          </a:p>
+        </p:txBody>
+      </p:sp>
+      <p:sp>
+        <p:nvSpPr>
+          <p:cNvPr id="5" name="TextBox 4"/>
+          <p:cNvSpPr txBox="1"/>
+          <p:nvPr/>
+        </p:nvSpPr>
+        <p:spPr>
+          <a:xfrm>
+            <a:off x="640080" y="1234440"/>
+            <a:ext cx="10972800" cy="5212080"/>
+          </a:xfrm>
+          <a:prstGeom prst="rect">
+            <a:avLst/>
+          </a:prstGeom>
+          <a:noFill/>
+        </p:spPr>
+        <p:txBody>
+          <a:bodyPr wrap="square" anchor="t" lIns="36576" rIns="36576" tIns="36576" bIns="36576">
+            <a:spAutoFit/>
+          </a:bodyPr>
+          <a:lstStyle/>
+          <a:p>
+            <a:pPr>
+              <a:spcAft>
+                <a:spcPts val="900"/>
+              </a:spcAft>
+            </a:pPr>
+            <a:r>
+              <a:rPr sz="1500" b="1" i="0">
+                <a:solidFill>
+                  <a:srgbClr val="1E88A8"/>
+                </a:solidFill>
+                <a:latin typeface="Calibri"/>
+              </a:rPr>
+              <a:t>[1]  </a:t>
+            </a:r>
+            <a:r>
+              <a:rPr sz="1500" b="0" i="0">
+                <a:solidFill>
+                  <a:srgbClr val="20282C"/>
+                </a:solidFill>
+                <a:latin typeface="Calibri"/>
+              </a:rPr>
+              <a:t>Kermack, W. O., McKendrick, A. G. (1927). A Contribution to the Mathematical Theory of Epidemics. Proc. Royal Society A.</a:t>
+            </a:r>
+          </a:p>
+          <a:p>
+            <a:pPr>
+              <a:spcAft>
+                <a:spcPts val="900"/>
+              </a:spcAft>
+            </a:pPr>
+            <a:r>
+              <a:rPr sz="1500" b="1" i="0">
+                <a:solidFill>
+                  <a:srgbClr val="1E88A8"/>
+                </a:solidFill>
+                <a:latin typeface="Calibri"/>
+              </a:rPr>
+              <a:t>[2]  </a:t>
+            </a:r>
+            <a:r>
+              <a:rPr sz="1500" b="0" i="0">
+                <a:solidFill>
+                  <a:srgbClr val="20282C"/>
+                </a:solidFill>
+                <a:latin typeface="Calibri"/>
+              </a:rPr>
+              <a:t>Giordano, G. et al. (2020). Modelling the COVID-19 epidemic and implementation of population-wide interventions in Italy [SIDARTHE]. Nature Medicine.</a:t>
+            </a:r>
+          </a:p>
+          <a:p>
+            <a:pPr>
+              <a:spcAft>
+                <a:spcPts val="900"/>
+              </a:spcAft>
+            </a:pPr>
+            <a:r>
+              <a:rPr sz="1500" b="1" i="0">
+                <a:solidFill>
+                  <a:srgbClr val="1E88A8"/>
+                </a:solidFill>
+                <a:latin typeface="Calibri"/>
+              </a:rPr>
+              <a:t>[3]  </a:t>
+            </a:r>
+            <a:r>
+              <a:rPr sz="1500" b="0" i="0">
+                <a:solidFill>
+                  <a:srgbClr val="20282C"/>
+                </a:solidFill>
+                <a:latin typeface="Calibri"/>
+              </a:rPr>
+              <a:t>Hethcote, H. W. (2000). The Mathematics of Infectious Diseases. SIAM Review.</a:t>
+            </a:r>
+          </a:p>
+          <a:p>
+            <a:pPr>
+              <a:spcAft>
+                <a:spcPts val="900"/>
+              </a:spcAft>
+            </a:pPr>
+            <a:r>
+              <a:rPr sz="1500" b="1" i="0">
+                <a:solidFill>
+                  <a:srgbClr val="1E88A8"/>
+                </a:solidFill>
+                <a:latin typeface="Calibri"/>
+              </a:rPr>
+              <a:t>[4]  </a:t>
+            </a:r>
+            <a:r>
+              <a:rPr sz="1500" b="0" i="0">
+                <a:solidFill>
+                  <a:srgbClr val="20282C"/>
+                </a:solidFill>
+                <a:latin typeface="Calibri"/>
+              </a:rPr>
+              <a:t>Diekmann, O., Heesterbeek, J. A. P., Metz, J. A. J. (1990). On the Definition and the Computation of the Basic Reproduction Ratio R₀. J. Mathematical Biology.</a:t>
+            </a:r>
+          </a:p>
+          <a:p>
+            <a:pPr>
+              <a:spcAft>
+                <a:spcPts val="900"/>
+              </a:spcAft>
+            </a:pPr>
+            <a:r>
+              <a:rPr sz="1500" b="1" i="0">
+                <a:solidFill>
+                  <a:srgbClr val="1E88A8"/>
+                </a:solidFill>
+                <a:latin typeface="Calibri"/>
+              </a:rPr>
+              <a:t>[5]  </a:t>
+            </a:r>
+            <a:r>
+              <a:rPr sz="1500" b="0" i="0">
+                <a:solidFill>
+                  <a:srgbClr val="20282C"/>
+                </a:solidFill>
+                <a:latin typeface="Calibri"/>
+              </a:rPr>
+              <a:t>Hochreiter, S., Schmidhuber, J. (1997). Long Short-Term Memory. Neural Computation.</a:t>
+            </a:r>
+          </a:p>
+          <a:p>
+            <a:pPr>
+              <a:spcAft>
+                <a:spcPts val="900"/>
+              </a:spcAft>
+            </a:pPr>
+            <a:r>
+              <a:rPr sz="1500" b="1" i="0">
+                <a:solidFill>
+                  <a:srgbClr val="1E88A8"/>
+                </a:solidFill>
+                <a:latin typeface="Calibri"/>
+              </a:rPr>
+              <a:t>[6]  </a:t>
+            </a:r>
+            <a:r>
+              <a:rPr sz="1500" b="0" i="0">
+                <a:solidFill>
+                  <a:srgbClr val="20282C"/>
+                </a:solidFill>
+                <a:latin typeface="Calibri"/>
+              </a:rPr>
+              <a:t>Dormand, J. R., Prince, P. J. (1980). A Family of Embedded Runge-Kutta Formulae. J. Computational and Applied Mathematics.</a:t>
+            </a:r>
+          </a:p>
+          <a:p>
+            <a:pPr>
+              <a:spcAft>
+                <a:spcPts val="900"/>
+              </a:spcAft>
+            </a:pPr>
+            <a:r>
+              <a:rPr sz="1500" b="1" i="0">
+                <a:solidFill>
+                  <a:srgbClr val="1E88A8"/>
+                </a:solidFill>
+                <a:latin typeface="Calibri"/>
+              </a:rPr>
+              <a:t>[7]  </a:t>
+            </a:r>
+            <a:r>
+              <a:rPr sz="1500" b="0" i="0">
+                <a:solidFill>
+                  <a:srgbClr val="20282C"/>
+                </a:solidFill>
+                <a:latin typeface="Calibri"/>
+              </a:rPr>
+              <a:t>Soetaert, K., Petzoldt, T., Setzer, R. W. (2010). Solving Differential Equations in R: Package deSolve. J. Statistical Software.</a:t>
+            </a:r>
+          </a:p>
+          <a:p>
+            <a:pPr>
+              <a:spcAft>
+                <a:spcPts val="900"/>
+              </a:spcAft>
+            </a:pPr>
+            <a:r>
+              <a:rPr sz="1500" b="1" i="0">
+                <a:solidFill>
+                  <a:srgbClr val="1E88A8"/>
+                </a:solidFill>
+                <a:latin typeface="Calibri"/>
+              </a:rPr>
+              <a:t>[8]  </a:t>
+            </a:r>
+            <a:r>
+              <a:rPr sz="1500" b="0" i="0">
+                <a:solidFill>
+                  <a:srgbClr val="20282C"/>
+                </a:solidFill>
+                <a:latin typeface="Calibri"/>
+              </a:rPr>
+              <a:t>Rackauckas, C., Nie, Q. (2017). DifferentialEquations.jl — A Performant and Feature-Rich Ecosystem for Solving Differential Equations in Julia. J. Open Research Software.</a:t>
+            </a:r>
+          </a:p>
+          <a:p>
+            <a:pPr>
+              <a:spcAft>
+                <a:spcPts val="900"/>
+              </a:spcAft>
+            </a:pPr>
+            <a:r>
+              <a:rPr sz="1500" b="1" i="0">
+                <a:solidFill>
+                  <a:srgbClr val="1E88A8"/>
+                </a:solidFill>
+                <a:latin typeface="Calibri"/>
+              </a:rPr>
+              <a:t>[9]  </a:t>
+            </a:r>
+            <a:r>
+              <a:rPr sz="1500" b="0" i="0">
+                <a:solidFill>
+                  <a:srgbClr val="20282C"/>
+                </a:solidFill>
+                <a:latin typeface="Calibri"/>
+              </a:rPr>
+              <a:t>Virtanen, P. et al. (2020). SciPy 1.0: Fundamental Algorithms for Scientific Computing in Python. Nature Methods.</a:t>
+            </a:r>
+          </a:p>
+        </p:txBody>
+      </p:sp>
+      <p:sp>
+        <p:nvSpPr>
+          <p:cNvPr id="6" name="TextBox 5"/>
+          <p:cNvSpPr txBox="1"/>
+          <p:nvPr/>
+        </p:nvSpPr>
+        <p:spPr>
+          <a:xfrm>
+            <a:off x="11247120" y="6437376"/>
+            <a:ext cx="822960" cy="365760"/>
+          </a:xfrm>
+          <a:prstGeom prst="rect">
+            <a:avLst/>
+          </a:prstGeom>
+          <a:noFill/>
+        </p:spPr>
+        <p:txBody>
+          <a:bodyPr wrap="square" anchor="t" lIns="36576" rIns="36576" tIns="36576" bIns="36576">
+            <a:spAutoFit/>
+          </a:bodyPr>
+          <a:lstStyle/>
+          <a:p>
+            <a:pPr algn="r"/>
+            <a:r>
+              <a:rPr sz="1200" b="1" i="0">
+                <a:solidFill>
+                  <a:srgbClr val="6B767C"/>
+                </a:solidFill>
+                <a:latin typeface="Calibri"/>
+              </a:rPr>
+              <a:t>19</a:t>
+            </a:r>
+          </a:p>
+        </p:txBody>
+      </p:sp>
+    </p:spTree>
+  </p:cSld>
+  <p:clrMapOvr>
+    <a:masterClrMapping/>
+  </p:clrMapOvr>
+</p:sld>
+</file>
+
+<file path=ppt/slides/slide21.xml><?xml version="1.0" encoding="utf-8"?>
+<p:sld xmlns:a="http://schemas.openxmlformats.org/drawingml/2006/main" xmlns:p="http://schemas.openxmlformats.org/presentationml/2006/main" xmlns:r="http://schemas.openxmlformats.org/officeDocument/2006/relationships">
+  <p:cSld>
+    <p:spTree>
+      <p:nvGrpSpPr>
+        <p:cNvPr id="1" name=""/>
+        <p:cNvGrpSpPr/>
+        <p:nvPr/>
+      </p:nvGrpSpPr>
+      <p:grpSpPr/>
+      <p:sp>
+        <p:nvSpPr>
+          <p:cNvPr id="2" name="Rectangle 1"/>
+          <p:cNvSpPr/>
+          <p:nvPr/>
+        </p:nvSpPr>
+        <p:spPr>
+          <a:xfrm>
+            <a:off x="0" y="0"/>
+            <a:ext cx="12191695" cy="6858000"/>
+          </a:xfrm>
+          <a:prstGeom prst="rect">
+            <a:avLst/>
+          </a:prstGeom>
+          <a:solidFill>
+            <a:srgbClr val="FFFFFF"/>
+          </a:solidFill>
+          <a:ln>
+            <a:noFill/>
+          </a:ln>
+          <a:effectLst/>
+        </p:spPr>
+        <p:style>
+          <a:lnRef idx="1">
+            <a:schemeClr val="accent1"/>
+          </a:lnRef>
+          <a:fillRef idx="3">
+            <a:schemeClr val="accent1"/>
+          </a:fillRef>
+          <a:effectRef idx="2">
+            <a:schemeClr val="accent1"/>
+          </a:effectRef>
+          <a:fontRef idx="minor">
+            <a:schemeClr val="lt1"/>
+          </a:fontRef>
+        </p:style>
+        <p:txBody>
+          <a:bodyPr rtlCol="0" anchor="ctr"/>
+          <a:lstStyle/>
+          <a:p>
+            <a:pPr algn="ctr"/>
+          </a:p>
+        </p:txBody>
+      </p:sp>
+      <p:sp>
+        <p:nvSpPr>
+          <p:cNvPr id="3" name="Rectangle 2"/>
+          <p:cNvSpPr/>
+          <p:nvPr/>
+        </p:nvSpPr>
+        <p:spPr>
+          <a:xfrm>
+            <a:off x="0" y="2468880"/>
+            <a:ext cx="12191695" cy="1920240"/>
+          </a:xfrm>
+          <a:prstGeom prst="rect">
+            <a:avLst/>
+          </a:prstGeom>
+          <a:solidFill>
+            <a:srgbClr val="124A63"/>
+          </a:solidFill>
+          <a:ln>
+            <a:noFill/>
+          </a:ln>
+          <a:effectLst/>
+        </p:spPr>
+        <p:style>
+          <a:lnRef idx="1">
+            <a:schemeClr val="accent1"/>
+          </a:lnRef>
+          <a:fillRef idx="3">
+            <a:schemeClr val="accent1"/>
+          </a:fillRef>
+          <a:effectRef idx="2">
+            <a:schemeClr val="accent1"/>
+          </a:effectRef>
+          <a:fontRef idx="minor">
+            <a:schemeClr val="lt1"/>
+          </a:fontRef>
+        </p:style>
+        <p:txBody>
+          <a:bodyPr rtlCol="0" anchor="ctr"/>
+          <a:lstStyle/>
+          <a:p>
+            <a:pPr algn="ctr"/>
+          </a:p>
+        </p:txBody>
+      </p:sp>
+      <p:sp>
+        <p:nvSpPr>
+          <p:cNvPr id="4" name="TextBox 3"/>
+          <p:cNvSpPr txBox="1"/>
+          <p:nvPr/>
+        </p:nvSpPr>
+        <p:spPr>
+          <a:xfrm>
+            <a:off x="640080" y="2468880"/>
+            <a:ext cx="10972800" cy="1920240"/>
+          </a:xfrm>
+          <a:prstGeom prst="rect">
+            <a:avLst/>
+          </a:prstGeom>
+          <a:noFill/>
+        </p:spPr>
+        <p:txBody>
+          <a:bodyPr wrap="square" anchor="ctr" lIns="36576" rIns="36576" tIns="36576" bIns="36576">
+            <a:spAutoFit/>
+          </a:bodyPr>
+          <a:lstStyle/>
+          <a:p>
+            <a:pPr algn="ctr"/>
+            <a:r>
+              <a:rPr sz="4000" b="1" i="0">
+                <a:solidFill>
+                  <a:srgbClr val="FFFFFF"/>
+                </a:solidFill>
+                <a:latin typeface="Calibri"/>
+              </a:rPr>
+              <a:t>Vă mulțumesc!   Întrebări?</a:t>
+            </a:r>
+          </a:p>
+          <a:p>
+            <a:pPr algn="ctr">
+              <a:spcBef>
+                <a:spcPts val="1000"/>
+              </a:spcBef>
+            </a:pPr>
+            <a:r>
+              <a:rPr sz="1600" b="0" i="0">
+                <a:solidFill>
+                  <a:srgbClr val="CFE6EE"/>
+                </a:solidFill>
+                <a:latin typeface="Calibri"/>
+              </a:rPr>
+              <a:t>Geană Tudor-Bogdan  ·  Coordonator: Prof. Radu Rădescu</a:t>
             </a:r>
           </a:p>
         </p:txBody>

</xml_diff>